<commit_message>
Lamina de contexto DS 44 al inicio de las 14 presentaciones comerciales
</commit_message>
<xml_diff>
--- a/ventas-piezas/plan-core/Tazki_Presentacion_PlanCore.pptx
+++ b/ventas-piezas/plan-core/Tazki_Presentacion_PlanCore.pptx
@@ -6,6 +6,7 @@
   </p:sldMasterIdLst>
   <p:sldIdLst>
     <p:sldId id="256" r:id="rId7"/>
+    <p:sldId id="271" r:id="rId23"/>
     <p:sldId id="257" r:id="rId9"/>
     <p:sldId id="258" r:id="rId10"/>
     <p:sldId id="259" r:id="rId11"/>
@@ -6574,6 +6575,939 @@
                 <a:cs typeface="DM Sans"/>
               </a:rPr>
               <a:t>tazki.cl/contactanos</a:t>
+            </a:r>
+          </a:p>
+        </p:txBody>
+      </p:sp>
+    </p:spTree>
+  </p:cSld>
+  <p:clrMapOvr>
+    <a:masterClrMapping/>
+  </p:clrMapOvr>
+</p:sld>
+</file>
+
+<file path=ppt/slides/slide16.xml><?xml version="1.0" encoding="utf-8"?>
+<p:sld xmlns:a="http://schemas.openxmlformats.org/drawingml/2006/main" xmlns:p="http://schemas.openxmlformats.org/presentationml/2006/main" xmlns:r="http://schemas.openxmlformats.org/officeDocument/2006/relationships">
+  <p:cSld>
+    <p:spTree>
+      <p:nvGrpSpPr>
+        <p:cNvPr id="1" name=""/>
+        <p:cNvGrpSpPr/>
+        <p:nvPr/>
+      </p:nvGrpSpPr>
+      <p:grpSpPr/>
+      <p:sp>
+        <p:nvSpPr>
+          <p:cNvPr id="2" name="TextBox 1"/>
+          <p:cNvSpPr txBox="1"/>
+          <p:nvPr/>
+        </p:nvSpPr>
+        <p:spPr>
+          <a:xfrm>
+            <a:off x="45720" y="6784848"/>
+            <a:ext cx="274320" cy="54864"/>
+          </a:xfrm>
+          <a:prstGeom prst="rect">
+            <a:avLst/>
+          </a:prstGeom>
+          <a:noFill/>
+        </p:spPr>
+        <p:txBody>
+          <a:bodyPr wrap="square" lIns="0" rIns="0" tIns="0" bIns="0">
+            <a:spAutoFit/>
+          </a:bodyPr>
+          <a:lstStyle/>
+          <a:p>
+            <a:pPr>
+              <a:lnSpc>
+                <a:spcPct val="115000"/>
+              </a:lnSpc>
+              <a:spcAft>
+                <a:spcPts val="0"/>
+              </a:spcAft>
+            </a:pPr>
+            <a:r>
+              <a:rPr sz="100" b="0">
+                <a:solidFill>
+                  <a:srgbClr val="FFFFFF"/>
+                </a:solidFill>
+                <a:latin typeface="DM Sans"/>
+              </a:rPr>
+              <a:t>​</a:t>
+            </a:r>
+          </a:p>
+        </p:txBody>
+      </p:sp>
+      <p:sp>
+        <p:nvSpPr>
+          <p:cNvPr id="3" name="TextBox 2"/>
+          <p:cNvSpPr txBox="1"/>
+          <p:nvPr/>
+        </p:nvSpPr>
+        <p:spPr>
+          <a:xfrm>
+            <a:off x="822960" y="658368"/>
+            <a:ext cx="8229600" cy="274320"/>
+          </a:xfrm>
+          <a:prstGeom prst="rect">
+            <a:avLst/>
+          </a:prstGeom>
+          <a:noFill/>
+        </p:spPr>
+        <p:txBody>
+          <a:bodyPr wrap="square" lIns="0" rIns="0" tIns="0" bIns="0">
+            <a:spAutoFit/>
+          </a:bodyPr>
+          <a:lstStyle/>
+          <a:p>
+            <a:pPr>
+              <a:lnSpc>
+                <a:spcPct val="115000"/>
+              </a:lnSpc>
+              <a:spcAft>
+                <a:spcPts val="0"/>
+              </a:spcAft>
+            </a:pPr>
+            <a:r>
+              <a:rPr sz="1250" b="1">
+                <a:solidFill>
+                  <a:srgbClr val="1537D1"/>
+                </a:solidFill>
+                <a:latin typeface="DM Sans"/>
+              </a:rPr>
+              <a:t>EL CONTEXTO</a:t>
+            </a:r>
+          </a:p>
+        </p:txBody>
+      </p:sp>
+      <p:sp>
+        <p:nvSpPr>
+          <p:cNvPr id="4" name="TextBox 3"/>
+          <p:cNvSpPr txBox="1"/>
+          <p:nvPr/>
+        </p:nvSpPr>
+        <p:spPr>
+          <a:xfrm>
+            <a:off x="822960" y="960120"/>
+            <a:ext cx="10241280" cy="1097280"/>
+          </a:xfrm>
+          <a:prstGeom prst="rect">
+            <a:avLst/>
+          </a:prstGeom>
+          <a:noFill/>
+        </p:spPr>
+        <p:txBody>
+          <a:bodyPr wrap="square" lIns="0" rIns="0" tIns="0" bIns="0">
+            <a:spAutoFit/>
+          </a:bodyPr>
+          <a:lstStyle/>
+          <a:p>
+            <a:pPr>
+              <a:lnSpc>
+                <a:spcPct val="118000"/>
+              </a:lnSpc>
+              <a:spcAft>
+                <a:spcPts val="0"/>
+              </a:spcAft>
+            </a:pPr>
+            <a:r>
+              <a:rPr sz="3000" b="1">
+                <a:solidFill>
+                  <a:srgbClr val="0C1E50"/>
+                </a:solidFill>
+                <a:latin typeface="DM Sans"/>
+              </a:rPr>
+              <a:t>El DS 44 cambió lo que se te exige:</a:t>
+            </a:r>
+          </a:p>
+          <a:p>
+            <a:pPr>
+              <a:lnSpc>
+                <a:spcPct val="118000"/>
+              </a:lnSpc>
+              <a:spcAft>
+                <a:spcPts val="0"/>
+              </a:spcAft>
+            </a:pPr>
+            <a:r>
+              <a:rPr sz="3000" b="1">
+                <a:solidFill>
+                  <a:srgbClr val="0C1E50"/>
+                </a:solidFill>
+                <a:latin typeface="DM Sans"/>
+              </a:rPr>
+              <a:t>ya no basta con tener los papeles.</a:t>
+            </a:r>
+          </a:p>
+        </p:txBody>
+      </p:sp>
+      <p:sp>
+        <p:nvSpPr>
+          <p:cNvPr id="5" name="TextBox 4"/>
+          <p:cNvSpPr txBox="1"/>
+          <p:nvPr/>
+        </p:nvSpPr>
+        <p:spPr>
+          <a:xfrm>
+            <a:off x="841248" y="1993392"/>
+            <a:ext cx="9692640" cy="640080"/>
+          </a:xfrm>
+          <a:prstGeom prst="rect">
+            <a:avLst/>
+          </a:prstGeom>
+          <a:noFill/>
+        </p:spPr>
+        <p:txBody>
+          <a:bodyPr wrap="square" lIns="0" rIns="0" tIns="0" bIns="0">
+            <a:spAutoFit/>
+          </a:bodyPr>
+          <a:lstStyle/>
+          <a:p>
+            <a:pPr>
+              <a:lnSpc>
+                <a:spcPct val="135000"/>
+              </a:lnSpc>
+              <a:spcAft>
+                <a:spcPts val="0"/>
+              </a:spcAft>
+            </a:pPr>
+            <a:r>
+              <a:rPr sz="1450" b="0">
+                <a:solidFill>
+                  <a:srgbClr val="5B6472"/>
+                </a:solidFill>
+                <a:latin typeface="DM Sans"/>
+              </a:rPr>
+              <a:t>Desde 2025 la prevención dejó de medirse por documentos archivados y pasó a medirse por gestión demostrable. Estas son las tres exigencias que cambiaron el día a día.</a:t>
+            </a:r>
+          </a:p>
+        </p:txBody>
+      </p:sp>
+      <p:sp>
+        <p:nvSpPr>
+          <p:cNvPr id="6" name="Rounded Rectangle 5"/>
+          <p:cNvSpPr/>
+          <p:nvPr/>
+        </p:nvSpPr>
+        <p:spPr>
+          <a:xfrm>
+            <a:off x="822960" y="2880360"/>
+            <a:ext cx="3429000" cy="2514600"/>
+          </a:xfrm>
+          <a:prstGeom prst="roundRect">
+            <a:avLst>
+              <a:gd name="adj" fmla="val 4500"/>
+            </a:avLst>
+          </a:prstGeom>
+          <a:solidFill>
+            <a:srgbClr val="F4F6FB"/>
+          </a:solidFill>
+          <a:ln>
+            <a:noFill/>
+          </a:ln>
+          <a:effectLst/>
+        </p:spPr>
+        <p:style>
+          <a:lnRef idx="1">
+            <a:schemeClr val="accent1"/>
+          </a:lnRef>
+          <a:fillRef idx="3">
+            <a:schemeClr val="accent1"/>
+          </a:fillRef>
+          <a:effectRef idx="2">
+            <a:schemeClr val="accent1"/>
+          </a:effectRef>
+          <a:fontRef idx="minor">
+            <a:schemeClr val="lt1"/>
+          </a:fontRef>
+        </p:style>
+        <p:txBody>
+          <a:bodyPr rtlCol="0" anchor="ctr"/>
+          <a:lstStyle/>
+          <a:p/>
+        </p:txBody>
+      </p:sp>
+      <p:sp>
+        <p:nvSpPr>
+          <p:cNvPr id="7" name="Rounded Rectangle 6"/>
+          <p:cNvSpPr/>
+          <p:nvPr/>
+        </p:nvSpPr>
+        <p:spPr>
+          <a:xfrm>
+            <a:off x="1143000" y="3200400"/>
+            <a:ext cx="457200" cy="457200"/>
+          </a:xfrm>
+          <a:prstGeom prst="roundRect">
+            <a:avLst>
+              <a:gd name="adj" fmla="val 50000"/>
+            </a:avLst>
+          </a:prstGeom>
+          <a:solidFill>
+            <a:srgbClr val="FFFFFF"/>
+          </a:solidFill>
+          <a:ln>
+            <a:noFill/>
+          </a:ln>
+          <a:effectLst/>
+        </p:spPr>
+        <p:style>
+          <a:lnRef idx="1">
+            <a:schemeClr val="accent1"/>
+          </a:lnRef>
+          <a:fillRef idx="3">
+            <a:schemeClr val="accent1"/>
+          </a:fillRef>
+          <a:effectRef idx="2">
+            <a:schemeClr val="accent1"/>
+          </a:effectRef>
+          <a:fontRef idx="minor">
+            <a:schemeClr val="lt1"/>
+          </a:fontRef>
+        </p:style>
+        <p:txBody>
+          <a:bodyPr rtlCol="0" anchor="ctr"/>
+          <a:lstStyle/>
+          <a:p/>
+        </p:txBody>
+      </p:sp>
+      <p:sp>
+        <p:nvSpPr>
+          <p:cNvPr id="8" name="TextBox 7"/>
+          <p:cNvSpPr txBox="1"/>
+          <p:nvPr/>
+        </p:nvSpPr>
+        <p:spPr>
+          <a:xfrm>
+            <a:off x="1143000" y="3291840"/>
+            <a:ext cx="457200" cy="274320"/>
+          </a:xfrm>
+          <a:prstGeom prst="rect">
+            <a:avLst/>
+          </a:prstGeom>
+          <a:noFill/>
+        </p:spPr>
+        <p:txBody>
+          <a:bodyPr wrap="square" lIns="0" rIns="0" tIns="0" bIns="0">
+            <a:spAutoFit/>
+          </a:bodyPr>
+          <a:lstStyle/>
+          <a:p>
+            <a:pPr algn="ctr">
+              <a:lnSpc>
+                <a:spcPct val="115000"/>
+              </a:lnSpc>
+              <a:spcAft>
+                <a:spcPts val="0"/>
+              </a:spcAft>
+            </a:pPr>
+            <a:r>
+              <a:rPr sz="1500" b="1">
+                <a:solidFill>
+                  <a:srgbClr val="1537D1"/>
+                </a:solidFill>
+                <a:latin typeface="DM Sans"/>
+              </a:rPr>
+              <a:t>1</a:t>
+            </a:r>
+          </a:p>
+        </p:txBody>
+      </p:sp>
+      <p:sp>
+        <p:nvSpPr>
+          <p:cNvPr id="9" name="TextBox 8"/>
+          <p:cNvSpPr txBox="1"/>
+          <p:nvPr/>
+        </p:nvSpPr>
+        <p:spPr>
+          <a:xfrm>
+            <a:off x="1143000" y="3840480"/>
+            <a:ext cx="2788920" cy="640080"/>
+          </a:xfrm>
+          <a:prstGeom prst="rect">
+            <a:avLst/>
+          </a:prstGeom>
+          <a:noFill/>
+        </p:spPr>
+        <p:txBody>
+          <a:bodyPr wrap="square" lIns="0" rIns="0" tIns="0" bIns="0">
+            <a:spAutoFit/>
+          </a:bodyPr>
+          <a:lstStyle/>
+          <a:p>
+            <a:pPr>
+              <a:lnSpc>
+                <a:spcPct val="120000"/>
+              </a:lnSpc>
+              <a:spcAft>
+                <a:spcPts val="0"/>
+              </a:spcAft>
+            </a:pPr>
+            <a:r>
+              <a:rPr sz="1550" b="1">
+                <a:solidFill>
+                  <a:srgbClr val="0C1E50"/>
+                </a:solidFill>
+                <a:latin typeface="DM Sans"/>
+              </a:rPr>
+              <a:t>La ODI se convirtió en IRL</a:t>
+            </a:r>
+          </a:p>
+        </p:txBody>
+      </p:sp>
+      <p:sp>
+        <p:nvSpPr>
+          <p:cNvPr id="10" name="TextBox 9"/>
+          <p:cNvSpPr txBox="1"/>
+          <p:nvPr/>
+        </p:nvSpPr>
+        <p:spPr>
+          <a:xfrm>
+            <a:off x="1161288" y="4407408"/>
+            <a:ext cx="2770632" cy="1371600"/>
+          </a:xfrm>
+          <a:prstGeom prst="rect">
+            <a:avLst/>
+          </a:prstGeom>
+          <a:noFill/>
+        </p:spPr>
+        <p:txBody>
+          <a:bodyPr wrap="square" lIns="0" rIns="0" tIns="0" bIns="0">
+            <a:spAutoFit/>
+          </a:bodyPr>
+          <a:lstStyle/>
+          <a:p>
+            <a:pPr>
+              <a:lnSpc>
+                <a:spcPct val="135000"/>
+              </a:lnSpc>
+              <a:spcAft>
+                <a:spcPts val="0"/>
+              </a:spcAft>
+            </a:pPr>
+            <a:r>
+              <a:rPr sz="1100" b="0">
+                <a:solidFill>
+                  <a:srgbClr val="5B6472"/>
+                </a:solidFill>
+                <a:latin typeface="DM Sans"/>
+              </a:rPr>
+              <a:t>Ahora hay que informar los riesgos de cada puesto de trabajo, dejar firma de que la persona los conoció y actualizar esa información cada vez que el riesgo o la tarea cambian.</a:t>
+            </a:r>
+          </a:p>
+        </p:txBody>
+      </p:sp>
+      <p:sp>
+        <p:nvSpPr>
+          <p:cNvPr id="11" name="Rounded Rectangle 10"/>
+          <p:cNvSpPr/>
+          <p:nvPr/>
+        </p:nvSpPr>
+        <p:spPr>
+          <a:xfrm>
+            <a:off x="4434840" y="2880360"/>
+            <a:ext cx="3429000" cy="2514600"/>
+          </a:xfrm>
+          <a:prstGeom prst="roundRect">
+            <a:avLst>
+              <a:gd name="adj" fmla="val 4500"/>
+            </a:avLst>
+          </a:prstGeom>
+          <a:solidFill>
+            <a:srgbClr val="F4F6FB"/>
+          </a:solidFill>
+          <a:ln>
+            <a:noFill/>
+          </a:ln>
+          <a:effectLst/>
+        </p:spPr>
+        <p:style>
+          <a:lnRef idx="1">
+            <a:schemeClr val="accent1"/>
+          </a:lnRef>
+          <a:fillRef idx="3">
+            <a:schemeClr val="accent1"/>
+          </a:fillRef>
+          <a:effectRef idx="2">
+            <a:schemeClr val="accent1"/>
+          </a:effectRef>
+          <a:fontRef idx="minor">
+            <a:schemeClr val="lt1"/>
+          </a:fontRef>
+        </p:style>
+        <p:txBody>
+          <a:bodyPr rtlCol="0" anchor="ctr"/>
+          <a:lstStyle/>
+          <a:p/>
+        </p:txBody>
+      </p:sp>
+      <p:sp>
+        <p:nvSpPr>
+          <p:cNvPr id="12" name="Rounded Rectangle 11"/>
+          <p:cNvSpPr/>
+          <p:nvPr/>
+        </p:nvSpPr>
+        <p:spPr>
+          <a:xfrm>
+            <a:off x="4754879" y="3200400"/>
+            <a:ext cx="457200" cy="457200"/>
+          </a:xfrm>
+          <a:prstGeom prst="roundRect">
+            <a:avLst>
+              <a:gd name="adj" fmla="val 50000"/>
+            </a:avLst>
+          </a:prstGeom>
+          <a:solidFill>
+            <a:srgbClr val="FFFFFF"/>
+          </a:solidFill>
+          <a:ln>
+            <a:noFill/>
+          </a:ln>
+          <a:effectLst/>
+        </p:spPr>
+        <p:style>
+          <a:lnRef idx="1">
+            <a:schemeClr val="accent1"/>
+          </a:lnRef>
+          <a:fillRef idx="3">
+            <a:schemeClr val="accent1"/>
+          </a:fillRef>
+          <a:effectRef idx="2">
+            <a:schemeClr val="accent1"/>
+          </a:effectRef>
+          <a:fontRef idx="minor">
+            <a:schemeClr val="lt1"/>
+          </a:fontRef>
+        </p:style>
+        <p:txBody>
+          <a:bodyPr rtlCol="0" anchor="ctr"/>
+          <a:lstStyle/>
+          <a:p/>
+        </p:txBody>
+      </p:sp>
+      <p:sp>
+        <p:nvSpPr>
+          <p:cNvPr id="13" name="TextBox 12"/>
+          <p:cNvSpPr txBox="1"/>
+          <p:nvPr/>
+        </p:nvSpPr>
+        <p:spPr>
+          <a:xfrm>
+            <a:off x="4754879" y="3291840"/>
+            <a:ext cx="457200" cy="274320"/>
+          </a:xfrm>
+          <a:prstGeom prst="rect">
+            <a:avLst/>
+          </a:prstGeom>
+          <a:noFill/>
+        </p:spPr>
+        <p:txBody>
+          <a:bodyPr wrap="square" lIns="0" rIns="0" tIns="0" bIns="0">
+            <a:spAutoFit/>
+          </a:bodyPr>
+          <a:lstStyle/>
+          <a:p>
+            <a:pPr algn="ctr">
+              <a:lnSpc>
+                <a:spcPct val="115000"/>
+              </a:lnSpc>
+              <a:spcAft>
+                <a:spcPts val="0"/>
+              </a:spcAft>
+            </a:pPr>
+            <a:r>
+              <a:rPr sz="1500" b="1">
+                <a:solidFill>
+                  <a:srgbClr val="1537D1"/>
+                </a:solidFill>
+                <a:latin typeface="DM Sans"/>
+              </a:rPr>
+              <a:t>2</a:t>
+            </a:r>
+          </a:p>
+        </p:txBody>
+      </p:sp>
+      <p:sp>
+        <p:nvSpPr>
+          <p:cNvPr id="14" name="TextBox 13"/>
+          <p:cNvSpPr txBox="1"/>
+          <p:nvPr/>
+        </p:nvSpPr>
+        <p:spPr>
+          <a:xfrm>
+            <a:off x="4754879" y="3840480"/>
+            <a:ext cx="2788920" cy="640080"/>
+          </a:xfrm>
+          <a:prstGeom prst="rect">
+            <a:avLst/>
+          </a:prstGeom>
+          <a:noFill/>
+        </p:spPr>
+        <p:txBody>
+          <a:bodyPr wrap="square" lIns="0" rIns="0" tIns="0" bIns="0">
+            <a:spAutoFit/>
+          </a:bodyPr>
+          <a:lstStyle/>
+          <a:p>
+            <a:pPr>
+              <a:lnSpc>
+                <a:spcPct val="120000"/>
+              </a:lnSpc>
+              <a:spcAft>
+                <a:spcPts val="0"/>
+              </a:spcAft>
+            </a:pPr>
+            <a:r>
+              <a:rPr sz="1550" b="1">
+                <a:solidFill>
+                  <a:srgbClr val="0C1E50"/>
+                </a:solidFill>
+                <a:latin typeface="DM Sans"/>
+              </a:rPr>
+              <a:t>La MIPER manda el programa</a:t>
+            </a:r>
+          </a:p>
+        </p:txBody>
+      </p:sp>
+      <p:sp>
+        <p:nvSpPr>
+          <p:cNvPr id="15" name="TextBox 14"/>
+          <p:cNvSpPr txBox="1"/>
+          <p:nvPr/>
+        </p:nvSpPr>
+        <p:spPr>
+          <a:xfrm>
+            <a:off x="4773168" y="4407408"/>
+            <a:ext cx="2770632" cy="1371600"/>
+          </a:xfrm>
+          <a:prstGeom prst="rect">
+            <a:avLst/>
+          </a:prstGeom>
+          <a:noFill/>
+        </p:spPr>
+        <p:txBody>
+          <a:bodyPr wrap="square" lIns="0" rIns="0" tIns="0" bIns="0">
+            <a:spAutoFit/>
+          </a:bodyPr>
+          <a:lstStyle/>
+          <a:p>
+            <a:pPr>
+              <a:lnSpc>
+                <a:spcPct val="135000"/>
+              </a:lnSpc>
+              <a:spcAft>
+                <a:spcPts val="0"/>
+              </a:spcAft>
+            </a:pPr>
+            <a:r>
+              <a:rPr sz="1100" b="0">
+                <a:solidFill>
+                  <a:srgbClr val="5B6472"/>
+                </a:solidFill>
+                <a:latin typeface="DM Sans"/>
+              </a:rPr>
+              <a:t>La matriz de peligros define el programa de trabajo preventivo, y ese programa debe elaborarse o modificarse dentro de los 30 días siguientes a confeccionar o actualizar la matriz.</a:t>
+            </a:r>
+          </a:p>
+        </p:txBody>
+      </p:sp>
+      <p:sp>
+        <p:nvSpPr>
+          <p:cNvPr id="16" name="Rounded Rectangle 15"/>
+          <p:cNvSpPr/>
+          <p:nvPr/>
+        </p:nvSpPr>
+        <p:spPr>
+          <a:xfrm>
+            <a:off x="8046720" y="2880360"/>
+            <a:ext cx="3429000" cy="2514600"/>
+          </a:xfrm>
+          <a:prstGeom prst="roundRect">
+            <a:avLst>
+              <a:gd name="adj" fmla="val 4500"/>
+            </a:avLst>
+          </a:prstGeom>
+          <a:solidFill>
+            <a:srgbClr val="F4F6FB"/>
+          </a:solidFill>
+          <a:ln>
+            <a:noFill/>
+          </a:ln>
+          <a:effectLst/>
+        </p:spPr>
+        <p:style>
+          <a:lnRef idx="1">
+            <a:schemeClr val="accent1"/>
+          </a:lnRef>
+          <a:fillRef idx="3">
+            <a:schemeClr val="accent1"/>
+          </a:fillRef>
+          <a:effectRef idx="2">
+            <a:schemeClr val="accent1"/>
+          </a:effectRef>
+          <a:fontRef idx="minor">
+            <a:schemeClr val="lt1"/>
+          </a:fontRef>
+        </p:style>
+        <p:txBody>
+          <a:bodyPr rtlCol="0" anchor="ctr"/>
+          <a:lstStyle/>
+          <a:p/>
+        </p:txBody>
+      </p:sp>
+      <p:sp>
+        <p:nvSpPr>
+          <p:cNvPr id="17" name="Rounded Rectangle 16"/>
+          <p:cNvSpPr/>
+          <p:nvPr/>
+        </p:nvSpPr>
+        <p:spPr>
+          <a:xfrm>
+            <a:off x="8366760" y="3200400"/>
+            <a:ext cx="457200" cy="457200"/>
+          </a:xfrm>
+          <a:prstGeom prst="roundRect">
+            <a:avLst>
+              <a:gd name="adj" fmla="val 50000"/>
+            </a:avLst>
+          </a:prstGeom>
+          <a:solidFill>
+            <a:srgbClr val="FFFFFF"/>
+          </a:solidFill>
+          <a:ln>
+            <a:noFill/>
+          </a:ln>
+          <a:effectLst/>
+        </p:spPr>
+        <p:style>
+          <a:lnRef idx="1">
+            <a:schemeClr val="accent1"/>
+          </a:lnRef>
+          <a:fillRef idx="3">
+            <a:schemeClr val="accent1"/>
+          </a:fillRef>
+          <a:effectRef idx="2">
+            <a:schemeClr val="accent1"/>
+          </a:effectRef>
+          <a:fontRef idx="minor">
+            <a:schemeClr val="lt1"/>
+          </a:fontRef>
+        </p:style>
+        <p:txBody>
+          <a:bodyPr rtlCol="0" anchor="ctr"/>
+          <a:lstStyle/>
+          <a:p/>
+        </p:txBody>
+      </p:sp>
+      <p:sp>
+        <p:nvSpPr>
+          <p:cNvPr id="18" name="TextBox 17"/>
+          <p:cNvSpPr txBox="1"/>
+          <p:nvPr/>
+        </p:nvSpPr>
+        <p:spPr>
+          <a:xfrm>
+            <a:off x="8366760" y="3291840"/>
+            <a:ext cx="457200" cy="274320"/>
+          </a:xfrm>
+          <a:prstGeom prst="rect">
+            <a:avLst/>
+          </a:prstGeom>
+          <a:noFill/>
+        </p:spPr>
+        <p:txBody>
+          <a:bodyPr wrap="square" lIns="0" rIns="0" tIns="0" bIns="0">
+            <a:spAutoFit/>
+          </a:bodyPr>
+          <a:lstStyle/>
+          <a:p>
+            <a:pPr algn="ctr">
+              <a:lnSpc>
+                <a:spcPct val="115000"/>
+              </a:lnSpc>
+              <a:spcAft>
+                <a:spcPts val="0"/>
+              </a:spcAft>
+            </a:pPr>
+            <a:r>
+              <a:rPr sz="1500" b="1">
+                <a:solidFill>
+                  <a:srgbClr val="1537D1"/>
+                </a:solidFill>
+                <a:latin typeface="DM Sans"/>
+              </a:rPr>
+              <a:t>3</a:t>
+            </a:r>
+          </a:p>
+        </p:txBody>
+      </p:sp>
+      <p:sp>
+        <p:nvSpPr>
+          <p:cNvPr id="19" name="TextBox 18"/>
+          <p:cNvSpPr txBox="1"/>
+          <p:nvPr/>
+        </p:nvSpPr>
+        <p:spPr>
+          <a:xfrm>
+            <a:off x="8366760" y="3840480"/>
+            <a:ext cx="2788920" cy="640080"/>
+          </a:xfrm>
+          <a:prstGeom prst="rect">
+            <a:avLst/>
+          </a:prstGeom>
+          <a:noFill/>
+        </p:spPr>
+        <p:txBody>
+          <a:bodyPr wrap="square" lIns="0" rIns="0" tIns="0" bIns="0">
+            <a:spAutoFit/>
+          </a:bodyPr>
+          <a:lstStyle/>
+          <a:p>
+            <a:pPr>
+              <a:lnSpc>
+                <a:spcPct val="120000"/>
+              </a:lnSpc>
+              <a:spcAft>
+                <a:spcPts val="0"/>
+              </a:spcAft>
+            </a:pPr>
+            <a:r>
+              <a:rPr sz="1550" b="1">
+                <a:solidFill>
+                  <a:srgbClr val="0C1E50"/>
+                </a:solidFill>
+                <a:latin typeface="DM Sans"/>
+              </a:rPr>
+              <a:t>La fiscalización pide evidencia</a:t>
+            </a:r>
+          </a:p>
+        </p:txBody>
+      </p:sp>
+      <p:sp>
+        <p:nvSpPr>
+          <p:cNvPr id="20" name="TextBox 19"/>
+          <p:cNvSpPr txBox="1"/>
+          <p:nvPr/>
+        </p:nvSpPr>
+        <p:spPr>
+          <a:xfrm>
+            <a:off x="8385048" y="4407408"/>
+            <a:ext cx="2770632" cy="1371600"/>
+          </a:xfrm>
+          <a:prstGeom prst="rect">
+            <a:avLst/>
+          </a:prstGeom>
+          <a:noFill/>
+        </p:spPr>
+        <p:txBody>
+          <a:bodyPr wrap="square" lIns="0" rIns="0" tIns="0" bIns="0">
+            <a:spAutoFit/>
+          </a:bodyPr>
+          <a:lstStyle/>
+          <a:p>
+            <a:pPr>
+              <a:lnSpc>
+                <a:spcPct val="135000"/>
+              </a:lnSpc>
+              <a:spcAft>
+                <a:spcPts val="0"/>
+              </a:spcAft>
+            </a:pPr>
+            <a:r>
+              <a:rPr sz="1100" b="0">
+                <a:solidFill>
+                  <a:srgbClr val="5B6472"/>
+                </a:solidFill>
+                <a:latin typeface="DM Sans"/>
+              </a:rPr>
+              <a:t>El Formulario Único de Fiscalización no revisa si el documento existe: revisa fecha, responsable, firma y seguimiento. Sin trazabilidad, no hay cómo demostrar la gestión.</a:t>
+            </a:r>
+          </a:p>
+        </p:txBody>
+      </p:sp>
+      <p:sp>
+        <p:nvSpPr>
+          <p:cNvPr id="21" name="Rectangle 20"/>
+          <p:cNvSpPr/>
+          <p:nvPr/>
+        </p:nvSpPr>
+        <p:spPr>
+          <a:xfrm>
+            <a:off x="0" y="5943600"/>
+            <a:ext cx="12188952" cy="914400"/>
+          </a:xfrm>
+          <a:prstGeom prst="rect">
+            <a:avLst/>
+          </a:prstGeom>
+          <a:solidFill>
+            <a:srgbClr val="1537D1"/>
+          </a:solidFill>
+          <a:ln>
+            <a:noFill/>
+          </a:ln>
+          <a:effectLst/>
+        </p:spPr>
+        <p:style>
+          <a:lnRef idx="1">
+            <a:schemeClr val="accent1"/>
+          </a:lnRef>
+          <a:fillRef idx="3">
+            <a:schemeClr val="accent1"/>
+          </a:fillRef>
+          <a:effectRef idx="2">
+            <a:schemeClr val="accent1"/>
+          </a:effectRef>
+          <a:fontRef idx="minor">
+            <a:schemeClr val="lt1"/>
+          </a:fontRef>
+        </p:style>
+        <p:txBody>
+          <a:bodyPr rtlCol="0" anchor="ctr"/>
+          <a:lstStyle/>
+          <a:p>
+            <a:pPr algn="ctr"/>
+          </a:p>
+        </p:txBody>
+      </p:sp>
+      <p:sp>
+        <p:nvSpPr>
+          <p:cNvPr id="22" name="TextBox 21"/>
+          <p:cNvSpPr txBox="1"/>
+          <p:nvPr/>
+        </p:nvSpPr>
+        <p:spPr>
+          <a:xfrm>
+            <a:off x="822960" y="6245352"/>
+            <a:ext cx="10515600" cy="365760"/>
+          </a:xfrm>
+          <a:prstGeom prst="rect">
+            <a:avLst/>
+          </a:prstGeom>
+          <a:noFill/>
+        </p:spPr>
+        <p:txBody>
+          <a:bodyPr wrap="square" lIns="0" rIns="0" tIns="0" bIns="0">
+            <a:spAutoFit/>
+          </a:bodyPr>
+          <a:lstStyle/>
+          <a:p>
+            <a:pPr>
+              <a:lnSpc>
+                <a:spcPct val="115000"/>
+              </a:lnSpc>
+              <a:spcAft>
+                <a:spcPts val="0"/>
+              </a:spcAft>
+            </a:pPr>
+            <a:r>
+              <a:rPr sz="1600" b="1">
+                <a:solidFill>
+                  <a:srgbClr val="FFFFFF"/>
+                </a:solidFill>
+                <a:latin typeface="DM Sans"/>
+              </a:rPr>
+              <a:t>Tazki es donde esa gestión queda registrada, al día y lista para mostrar.</a:t>
             </a:r>
           </a:p>
         </p:txBody>

</xml_diff>